<commit_message>
Corrections FX3, FIC et fichiers du dossier _todos
</commit_message>
<xml_diff>
--- a/_slides/remanies/14. FX3_slides.pptx
+++ b/_slides/remanies/14. FX3_slides.pptx
@@ -7035,6 +7035,7 @@
           </a:p>
           <a:p>
             <a:r>
+              <a:rPr/>
               <a:t>Pas à pas, de la vue au modèle</a:t>
             </a:r>
           </a:p>
@@ -16231,7 +16232,16 @@
                     <a:srgbClr val="E8E8E8"/>
                   </a:solidFill>
                 </a:rPr>
-                <a:t>devient premierNombre</a:t>
+                <a:t>devient </a:t>
+              </a:r>
+              <a:r>
+                <a:rPr lang="fr-BE" sz="1050" dirty="0">
+                  <a:solidFill>
+                    <a:schemeClr val="accent4"/>
+                  </a:solidFill>
+                  <a:latin typeface="Consolas"/>
+                </a:rPr>
+                <a:t>premierNombre</a:t>
               </a:r>
             </a:p>
           </p:txBody>
@@ -16314,7 +16324,24 @@
                     <a:srgbClr val="E8E8E8"/>
                   </a:solidFill>
                 </a:rPr>
-                <a:t>nombre affiché, operateurEnAttente)</a:t>
+                <a:t>nombre affiché, </a:t>
+              </a:r>
+              <a:r>
+                <a:rPr lang="fr-BE" sz="900" dirty="0">
+                  <a:solidFill>
+                    <a:schemeClr val="accent4"/>
+                  </a:solidFill>
+                  <a:latin typeface="Consolas"/>
+                </a:rPr>
+                <a:t>operateurEnAttente</a:t>
+              </a:r>
+              <a:r>
+                <a:rPr lang="fr-BE" sz="1000" dirty="0">
+                  <a:solidFill>
+                    <a:srgbClr val="E8E8E8"/>
+                  </a:solidFill>
+                </a:rPr>
+                <a:t>)</a:t>
               </a:r>
             </a:p>
             <a:p>
@@ -16325,7 +16352,16 @@
                     <a:srgbClr val="9DA0A8"/>
                   </a:solidFill>
                 </a:rPr>
-                <a:t>le résultat s'affiche et devient premierNombre</a:t>
+                <a:t>le résultat s'affiche et devient </a:t>
+              </a:r>
+              <a:r>
+                <a:rPr lang="fr-BE" sz="900" dirty="0">
+                  <a:solidFill>
+                    <a:schemeClr val="accent4"/>
+                  </a:solidFill>
+                  <a:latin typeface="Consolas"/>
+                </a:rPr>
+                <a:t>premierNombre</a:t>
               </a:r>
             </a:p>
           </p:txBody>
@@ -21778,7 +21814,7 @@
                   <a:latin typeface="Arial" panose="020B0604020202020204" pitchFamily="34" charset="0"/>
                   <a:cs typeface="Arial" panose="020B0604020202020204" pitchFamily="34" charset="0"/>
                 </a:rPr>
-                <a:t>:</a:t>
+                <a:t>/</a:t>
               </a:r>
             </a:p>
           </p:txBody>
@@ -22222,7 +22258,7 @@
           <p:spPr>
             <a:xfrm>
               <a:off x="7231996" y="5435389"/>
-              <a:ext cx="1581354" cy="552456"/>
+              <a:ext cx="712839" cy="552456"/>
             </a:xfrm>
             <a:prstGeom prst="rect">
               <a:avLst/>
@@ -22309,6 +22345,59 @@
                   <a:cs typeface="Arial" panose="020B0604020202020204" pitchFamily="34" charset="0"/>
                 </a:rPr>
                 <a:t>=</a:t>
+              </a:r>
+            </a:p>
+          </p:txBody>
+        </p:sp>
+        <p:sp>
+          <p:nvSpPr>
+            <p:cNvPr id="937" name="Rectangle 37">
+              <a:extLst>
+                <a:ext uri="{FF2B5EF4-FFF2-40B4-BE49-F238E27FC236}">
+                  <a16:creationId xmlns:a16="http://schemas.microsoft.com/office/drawing/2014/main" id="{6E11AACB-15BD-CF19-6736-CAB56BAB9777}"/>
+                </a:ext>
+              </a:extLst>
+            </p:cNvPr>
+            <p:cNvSpPr/>
+            <p:nvPr/>
+          </p:nvSpPr>
+          <p:spPr>
+            <a:xfrm>
+              <a:off x="8100513" y="5435389"/>
+              <a:ext cx="712839" cy="552456"/>
+            </a:xfrm>
+            <a:prstGeom prst="rect">
+              <a:avLst/>
+            </a:prstGeom>
+          </p:spPr>
+          <p:style>
+            <a:lnRef idx="0">
+              <a:schemeClr val="accent5"/>
+            </a:lnRef>
+            <a:fillRef idx="3">
+              <a:schemeClr val="accent5"/>
+            </a:fillRef>
+            <a:effectRef idx="3">
+              <a:schemeClr val="accent5"/>
+            </a:effectRef>
+            <a:fontRef idx="minor">
+              <a:schemeClr val="lt1"/>
+            </a:fontRef>
+          </p:style>
+          <p:txBody>
+            <a:bodyPr rtlCol="0" anchor="ctr"/>
+            <a:lstStyle/>
+            <a:p>
+              <a:pPr algn="ctr"/>
+              <a:r>
+                <a:rPr lang="fr-FR" sz="1600" dirty="0">
+                  <a:solidFill>
+                    <a:schemeClr val="tx1"/>
+                  </a:solidFill>
+                  <a:latin typeface="Arial" panose="020B0604020202020204" pitchFamily="34" charset="0"/>
+                  <a:cs typeface="Arial" panose="020B0604020202020204" pitchFamily="34" charset="0"/>
+                </a:rPr>
+                <a:t>C</a:t>
               </a:r>
             </a:p>
           </p:txBody>

</xml_diff>